<commit_message>
Deployed dedb52d with MkDocs version: 1.6.1
</commit_message>
<xml_diff>
--- a/ai/知识库搭建指南.pptx
+++ b/ai/知识库搭建指南.pptx
@@ -5669,7 +5669,7 @@
         <p:spPr>
           <a:xfrm>
             <a:off x="1366345" y="3026979"/>
-            <a:ext cx="1569660" cy="2031325"/>
+            <a:ext cx="1745671" cy="2031325"/>
           </a:xfrm>
           <a:prstGeom prst="rect">
             <a:avLst/>
@@ -5713,7 +5713,7 @@
           <a:p>
             <a:r>
               <a:rPr lang="en-US" altLang="zh-CN" dirty="0"/>
-              <a:t>git commit “”</a:t>
+              <a:t>git commit -m “”</a:t>
             </a:r>
           </a:p>
           <a:p>

</xml_diff>